<commit_message>
changes for mock presentation 10/03
</commit_message>
<xml_diff>
--- a/Presentation Draft.pptx
+++ b/Presentation Draft.pptx
@@ -3471,7 +3471,7 @@
         <p:spPr/>
         <p:txBody>
           <a:bodyPr>
-            <a:normAutofit fontScale="70000" lnSpcReduction="20000"/>
+            <a:normAutofit fontScale="55000" lnSpcReduction="20000"/>
           </a:bodyPr>
           <a:lstStyle/>
           <a:p>
@@ -3484,7 +3484,7 @@
             <a:pPr lvl="1"/>
             <a:r>
               <a:rPr lang="en-GB" dirty="0"/>
-              <a:t>What is SBI?</a:t>
+              <a:t>What is SBI – 2 slides?</a:t>
             </a:r>
           </a:p>
           <a:p>
@@ -3504,8 +3504,47 @@
           <a:p>
             <a:r>
               <a:rPr lang="en-GB" dirty="0"/>
+              <a:t>A list of tests from CMB papers, contours form SBI method, how to transfer – connect the two together</a:t>
+            </a:r>
+          </a:p>
+          <a:p>
+            <a:r>
+              <a:rPr lang="en-GB" dirty="0"/>
+              <a:t>Introduce my method, and how I aim to solve it (bridging gap between </a:t>
+            </a:r>
+            <a:r>
+              <a:rPr lang="en-GB" dirty="0" err="1"/>
+              <a:t>cmb</a:t>
+            </a:r>
+            <a:r>
+              <a:rPr lang="en-GB" dirty="0"/>
+              <a:t> techniques and </a:t>
+            </a:r>
+            <a:r>
+              <a:rPr lang="en-GB" dirty="0" err="1"/>
+              <a:t>sbi</a:t>
+            </a:r>
+            <a:r>
+              <a:rPr lang="en-GB" dirty="0"/>
+              <a:t> problems)</a:t>
+            </a:r>
+          </a:p>
+          <a:p>
+            <a:r>
+              <a:rPr lang="en-GB" dirty="0"/>
               <a:t>SBI Pipeline (short, 1 slide?)</a:t>
             </a:r>
+          </a:p>
+          <a:p>
+            <a:r>
+              <a:rPr lang="en-GB" dirty="0"/>
+              <a:t>KL </a:t>
+            </a:r>
+            <a:r>
+              <a:rPr lang="en-GB"/>
+              <a:t>Divergence explanation</a:t>
+            </a:r>
+            <a:endParaRPr lang="en-GB" dirty="0"/>
           </a:p>
           <a:p>
             <a:r>
@@ -3574,6 +3613,20 @@
             <a:r>
               <a:rPr lang="en-GB" dirty="0"/>
               <a:t>Need more here (pipeline only now working)</a:t>
+            </a:r>
+          </a:p>
+          <a:p>
+            <a:r>
+              <a:rPr lang="en-GB" dirty="0"/>
+              <a:t>Tuesday at 2pm: practice, get at least everything up till </a:t>
+            </a:r>
+            <a:r>
+              <a:rPr lang="en-GB" dirty="0" err="1"/>
+              <a:t>cmb</a:t>
+            </a:r>
+            <a:r>
+              <a:rPr lang="en-GB" dirty="0"/>
+              <a:t> done</a:t>
             </a:r>
           </a:p>
           <a:p>
@@ -3769,7 +3822,7 @@
           <a:p>
             <a:r>
               <a:rPr lang="en-GB" dirty="0"/>
-              <a:t>Systematic bias: e.g. consistent shift in something due to something</a:t>
+              <a:t>Systematic bias: e.g. consistent shift in something due to something (measurement error/faulty equipment)</a:t>
             </a:r>
           </a:p>
           <a:p>
@@ -3782,7 +3835,21 @@
             <a:pPr lvl="1"/>
             <a:r>
               <a:rPr lang="en-GB" dirty="0"/>
-              <a:t>Lensing</a:t>
+              <a:t>Beam miscalibration</a:t>
+            </a:r>
+          </a:p>
+          <a:p>
+            <a:pPr lvl="1"/>
+            <a:r>
+              <a:rPr lang="en-GB" dirty="0"/>
+              <a:t>Pointing errors</a:t>
+            </a:r>
+          </a:p>
+          <a:p>
+            <a:pPr lvl="1"/>
+            <a:r>
+              <a:rPr lang="en-GB" dirty="0"/>
+              <a:t>Correlated noise</a:t>
             </a:r>
           </a:p>
           <a:p>

</xml_diff>